<commit_message>
Sesión 6: la lámina de atribución ya no usa el expediente de un equipo
Las dos citas salían de la Entidad A, que es el expediente del equipo 1, y
la afirmación que no se sostiene era justamente el error que la clave del
instructor predice para ese equipo. Con eso, el equipo 1 entraba al
laboratorio con su hallazgo y su trampa servidos, y los otros cinco no.

Ahora las dos citas vienen del marco normativo que los seis comparten, y
ninguna corresponde al hallazgo central de nadie: artículo 11 para la
afirmación que se sostiene y artículo 14 para la que salta a un juicio,
donde confundir monto con suficiencia es el error clásico en evaluación
de transferencias.

De paso se corrige una cita truncada: la del artículo 21 cortaba la
oración a la mitad y la cerraba con punto, en la lámina que enseña
justamente a no hacer eso.

Co-Authored-By: Claude Opus 5 <noreply@anthropic.com>
</commit_message>
<xml_diff>
--- a/sesion-06/Sesion_06_Laboratorio_Cualitativo.pptx
+++ b/sesion-06/Sesion_06_Laboratorio_Cualitativo.pptx
@@ -1408,7 +1408,13 @@
           <a:p>
             <a:r>
               <a:rPr lang="en-US" dirty="0"/>
-              <a:t>El punto: la cita de la derecha es textual, está bien copiada y viene del expediente correcto. Aun así no sostiene la afirmación, porque saturación no es calidad.</a:t>
+              <a:t>El punto: la cita de la derecha es textual, está bien copiada y viene del artículo correcto. Aun así no sostiene la afirmación, porque un monto no es una medida de suficiencia. Es la confusión más común en evaluación de programas de transferencia.</a:t>
+            </a:r>
+          </a:p>
+          <a:p>
+            <a:r>
+              <a:rPr lang="en-US" dirty="0"/>
+              <a:t>Las dos citas salen del marco normativo común, a propósito: así ningún equipo recibe una pista sobre su propio expediente.</a:t>
             </a:r>
           </a:p>
           <a:p>
@@ -1421,6 +1427,12 @@
             <a:r>
               <a:rPr lang="en-US" dirty="0"/>
               <a:t>Si preguntan si el modelo puede revisar sus propias citas: no. Sin evidencia externa, la autocorrección degrada el resultado. Lo que sí funciona es ir a la fuente, que es lo que hace el paso 3 del laboratorio.</a:t>
+            </a:r>
+          </a:p>
+          <a:p>
+            <a:r>
+              <a:rPr lang="en-US" dirty="0"/>
+              <a:t>Una advertencia que vale para todo el laboratorio: la cita se copia completa. Cortar una oración a la mitad y cerrarla con punto ya cambia lo que dice. Si hay que recortar, se marca con puntos suspensivos.</a:t>
             </a:r>
           </a:p>
           <a:p>
@@ -9803,7 +9815,7 @@
                 <a:ea typeface="Calibri" pitchFamily="34" charset="-122"/>
                 <a:cs typeface="Calibri" pitchFamily="34" charset="-120"/>
               </a:rPr>
-              <a:t>Es la falla que el RAG de ayer no resuelve, porque recuperar el fragmento correcto y sostener la afirmación son dos cosas distintas.</a:t>
+              <a:t>Es la falla que el RAG de ayer no resuelve: recuperar el fragmento correcto y sostener la afirmación son dos cosas distintas. Las dos citas son del marco normativo que todos comparten.</a:t>
             </a:r>
             <a:endParaRPr lang="en-US" sz="1500" dirty="0"/>
           </a:p>
@@ -9908,7 +9920,7 @@
                 <a:ea typeface="Arial" pitchFamily="34" charset="-122"/>
                 <a:cs typeface="Arial" pitchFamily="34" charset="-120"/>
               </a:rPr>
-              <a:t>La cita dice exactamente eso</a:t>
+              <a:t>La afirmación no agrega nada</a:t>
             </a:r>
             <a:endParaRPr lang="en-US" sz="1600" dirty="0"/>
           </a:p>
@@ -9977,7 +9989,7 @@
                 <a:ea typeface="Calibri" pitchFamily="34" charset="-122"/>
                 <a:cs typeface="Calibri" pitchFamily="34" charset="-120"/>
               </a:rPr>
-              <a:t>«Contar con al menos una persona responsable por cada ocho niñas y niños menores de seis años atendidos.» Artículo 21, fracción I.</a:t>
+              <a:t>«El Programa es incompatible con otros programas federales de transferencia monetaria dirigidos a la misma persona cuidadora principal por el mismo concepto.» Artículo 11.</a:t>
             </a:r>
             <a:endParaRPr lang="en-US" sz="1200" dirty="0"/>
           </a:p>
@@ -10019,7 +10031,7 @@
                 <a:ea typeface="Calibri" pitchFamily="34" charset="-122"/>
                 <a:cs typeface="Calibri" pitchFamily="34" charset="-120"/>
               </a:rPr>
-              <a:t>Afirmación: la norma fija una relación máxima de una persona responsable por cada ocho menores. Quien lea solo la cita llega a la misma afirmación.</a:t>
+              <a:t>Afirmación: el Programa no puede concurrir con otro apoyo federal en efectivo para la misma persona cuidadora y por el mismo concepto. Quien lea solo la cita llega a lo mismo.</a:t>
             </a:r>
             <a:endParaRPr lang="en-US" sz="1250" dirty="0"/>
           </a:p>
@@ -10124,7 +10136,7 @@
                 <a:ea typeface="Arial" pitchFamily="34" charset="-122"/>
                 <a:cs typeface="Arial" pitchFamily="34" charset="-120"/>
               </a:rPr>
-              <a:t>La cita habla de otra cosa</a:t>
+              <a:t>La afirmación salta a un juicio</a:t>
             </a:r>
             <a:endParaRPr lang="en-US" sz="1600" dirty="0"/>
           </a:p>
@@ -10193,7 +10205,7 @@
                 <a:ea typeface="Calibri" pitchFamily="34" charset="-122"/>
                 <a:cs typeface="Calibri" pitchFamily="34" charset="-120"/>
               </a:rPr>
-              <a:t>«Los centros de la zona metropolitana operan al límite de su capacidad instalada y en seis de ellos existe lista de espera.» Informe estatal.</a:t>
+              <a:t>«El monto del apoyo es de 3,100 pesos bimestrales.» Artículo 14.</a:t>
             </a:r>
             <a:endParaRPr lang="en-US" sz="1200" dirty="0"/>
           </a:p>
@@ -10235,7 +10247,7 @@
                 <a:ea typeface="Calibri" pitchFamily="34" charset="-122"/>
                 <a:cs typeface="Calibri" pitchFamily="34" charset="-120"/>
               </a:rPr>
-              <a:t>Afirmación: la calidad del servicio en la zona metropolitana es mala. La cita documenta saturación, no calidad. La afirmación dice más que su evidencia.</a:t>
+              <a:t>Afirmación: el monto del apoyo es suficiente para cubrir el cuidado de una persona. La cita fija una cantidad y no dice nada sobre suficiencia. La afirmación dice más que su evidencia.</a:t>
             </a:r>
             <a:endParaRPr lang="en-US" sz="1250" dirty="0"/>
           </a:p>

</xml_diff>